<commit_message>
Touched up slides, index and readme
</commit_message>
<xml_diff>
--- a/PREDICTING VACCINE UPTAKE.pptx
+++ b/PREDICTING VACCINE UPTAKE.pptx
@@ -15868,11 +15868,19 @@
             </a:r>
             <a:r>
               <a:rPr lang="en-GB" b="1" dirty="0"/>
-              <a:t>Tuned Gradient Boost model </a:t>
+              <a:t>Tuned Random Forest model </a:t>
             </a:r>
             <a:r>
               <a:rPr lang="en-GB" dirty="0"/>
-              <a:t>demonstrated strong performance, proving to be a robust predictor of vaccine uptake.</a:t>
+              <a:t>demonstrated strong performance, </a:t>
+            </a:r>
+            <a:r>
+              <a:rPr lang="en-GB"/>
+              <a:t>proving to </a:t>
+            </a:r>
+            <a:r>
+              <a:rPr lang="en-GB" dirty="0"/>
+              <a:t>be a robust predictor of vaccine uptake.</a:t>
             </a:r>
           </a:p>
           <a:p>
@@ -19916,40 +19924,42 @@
           </a:bodyPr>
           <a:lstStyle/>
           <a:p>
-            <a:endParaRPr lang="en-US" sz="2200"/>
+            <a:endParaRPr lang="en-US" sz="2200" dirty="0"/>
           </a:p>
           <a:p>
             <a:r>
-              <a:rPr lang="en-US" sz="2200" b="1"/>
+              <a:rPr lang="en-US" sz="2200" b="1" dirty="0"/>
               <a:t>Tested Models: </a:t>
             </a:r>
             <a:r>
-              <a:rPr lang="en-US" sz="2200"/>
+              <a:rPr lang="en-US" sz="2200" dirty="0"/>
               <a:t>Logistic Regression, Decision Tree, Random Forest and Gradient Boost.</a:t>
             </a:r>
           </a:p>
           <a:p>
             <a:r>
-              <a:rPr lang="en-US" sz="2200" b="1"/>
+              <a:rPr lang="en-US" sz="2200" b="1" dirty="0"/>
               <a:t>Evaluation Metrics: </a:t>
             </a:r>
             <a:r>
-              <a:rPr lang="en-US" sz="2200"/>
+              <a:rPr lang="en-US" sz="2200" dirty="0"/>
               <a:t>Used recall and F1-score as main metrics. Also took note of accuracy, precision and AUC.</a:t>
             </a:r>
           </a:p>
           <a:p>
             <a:r>
-              <a:rPr lang="en-US" sz="2200" b="1"/>
+              <a:rPr lang="en-US" sz="2200" b="1" dirty="0"/>
               <a:t>Selected Model: </a:t>
             </a:r>
             <a:r>
-              <a:rPr lang="en-US" sz="2200"/>
-              <a:t>Gradient Boost had the best performance for H1N1 and seasonal flu prediction.</a:t>
+              <a:rPr lang="en-US" sz="2200" dirty="0"/>
+              <a:t>The </a:t>
             </a:r>
-          </a:p>
-          <a:p>
-            <a:endParaRPr lang="en-US" sz="2200"/>
+            <a:r>
+              <a:rPr lang="en-GB" sz="2200" dirty="0"/>
+              <a:t>tuned Random Forest was selected due to its strong performance in handling high-dimensional data, its ability to reduce overfitting, and its robust predictive accuracy, making it well-suited for this classification task.</a:t>
+            </a:r>
+            <a:endParaRPr lang="en-US" sz="2200" dirty="0"/>
           </a:p>
         </p:txBody>
       </p:sp>
@@ -20347,42 +20357,119 @@
       </p:sp>
       <p:sp>
         <p:nvSpPr>
-          <p:cNvPr id="3" name="Content Placeholder 2">
+          <p:cNvPr id="4" name="Rectangle 3">
             <a:extLst>
               <a:ext uri="{FF2B5EF4-FFF2-40B4-BE49-F238E27FC236}">
-                <a16:creationId xmlns:a16="http://schemas.microsoft.com/office/drawing/2014/main" id="{85323ADD-5EB6-4B0D-BF74-692310FCD33C}"/>
+                <a16:creationId xmlns:a16="http://schemas.microsoft.com/office/drawing/2014/main" id="{5B0BD175-A69D-974F-BFC5-A208DA1FE7EC}"/>
               </a:ext>
             </a:extLst>
           </p:cNvPr>
-          <p:cNvSpPr>
-            <a:spLocks noGrp="1"/>
-          </p:cNvSpPr>
-          <p:nvPr>
-            <p:ph idx="1"/>
-          </p:nvPr>
+          <p:cNvSpPr/>
+          <p:nvPr/>
         </p:nvSpPr>
         <p:spPr>
           <a:xfrm>
-            <a:off x="1115568" y="2481943"/>
-            <a:ext cx="10168128" cy="3695020"/>
+            <a:off x="5977217" y="3244334"/>
+            <a:ext cx="237566" cy="369332"/>
           </a:xfrm>
+          <a:prstGeom prst="rect">
+            <a:avLst/>
+          </a:prstGeom>
         </p:spPr>
         <p:txBody>
-          <a:bodyPr>
-            <a:normAutofit/>
+          <a:bodyPr wrap="none">
+            <a:spAutoFit/>
           </a:bodyPr>
           <a:lstStyle/>
           <a:p>
-            <a:endParaRPr lang="en-US" sz="2200"/>
-          </a:p>
-          <a:p>
-            <a:pPr marL="0" indent="0">
-              <a:buNone/>
-            </a:pPr>
-            <a:endParaRPr lang="en-US" sz="2200"/>
+            <a:r>
+              <a:rPr lang="en-GB" dirty="0"/>
+              <a:t> </a:t>
+            </a:r>
           </a:p>
         </p:txBody>
       </p:sp>
+      <p:sp>
+        <p:nvSpPr>
+          <p:cNvPr id="5" name="Rectangle 4">
+            <a:extLst>
+              <a:ext uri="{FF2B5EF4-FFF2-40B4-BE49-F238E27FC236}">
+                <a16:creationId xmlns:a16="http://schemas.microsoft.com/office/drawing/2014/main" id="{2FCD9B0D-9D6F-974B-9DE2-2A01310E1535}"/>
+              </a:ext>
+            </a:extLst>
+          </p:cNvPr>
+          <p:cNvSpPr/>
+          <p:nvPr/>
+        </p:nvSpPr>
+        <p:spPr>
+          <a:xfrm>
+            <a:off x="5977217" y="3244334"/>
+            <a:ext cx="237566" cy="369332"/>
+          </a:xfrm>
+          <a:prstGeom prst="rect">
+            <a:avLst/>
+          </a:prstGeom>
+        </p:spPr>
+        <p:txBody>
+          <a:bodyPr wrap="none">
+            <a:spAutoFit/>
+          </a:bodyPr>
+          <a:lstStyle/>
+          <a:p>
+            <a:r>
+              <a:rPr lang="en-GB" dirty="0"/>
+              <a:t> </a:t>
+            </a:r>
+          </a:p>
+        </p:txBody>
+      </p:sp>
+      <p:pic>
+        <p:nvPicPr>
+          <p:cNvPr id="1026" name="Picture 2">
+            <a:extLst>
+              <a:ext uri="{FF2B5EF4-FFF2-40B4-BE49-F238E27FC236}">
+                <a16:creationId xmlns:a16="http://schemas.microsoft.com/office/drawing/2014/main" id="{839AF122-A970-C84F-BBA7-4D7490016ECA}"/>
+              </a:ext>
+            </a:extLst>
+          </p:cNvPr>
+          <p:cNvPicPr>
+            <a:picLocks noChangeAspect="1" noChangeArrowheads="1"/>
+          </p:cNvPicPr>
+          <p:nvPr/>
+        </p:nvPicPr>
+        <p:blipFill>
+          <a:blip r:embed="rId2">
+            <a:extLst>
+              <a:ext uri="{28A0092B-C50C-407E-A947-70E740481C1C}">
+                <a14:useLocalDpi xmlns:a14="http://schemas.microsoft.com/office/drawing/2010/main" val="0"/>
+              </a:ext>
+            </a:extLst>
+          </a:blip>
+          <a:srcRect/>
+          <a:stretch>
+            <a:fillRect/>
+          </a:stretch>
+        </p:blipFill>
+        <p:spPr bwMode="auto">
+          <a:xfrm>
+            <a:off x="1112520" y="1573884"/>
+            <a:ext cx="8569569" cy="4818151"/>
+          </a:xfrm>
+          <a:prstGeom prst="rect">
+            <a:avLst/>
+          </a:prstGeom>
+          <a:noFill/>
+          <a:extLst>
+            <a:ext uri="{909E8E84-426E-40DD-AFC4-6F175D3DCCD1}">
+              <a14:hiddenFill xmlns:a14="http://schemas.microsoft.com/office/drawing/2010/main">
+                <a:solidFill>
+                  <a:srgbClr val="FFFFFF"/>
+                </a:solidFill>
+              </a14:hiddenFill>
+            </a:ext>
+          </a:extLst>
+        </p:spPr>
+      </p:pic>
     </p:spTree>
     <p:extLst>
       <p:ext uri="{BB962C8B-B14F-4D97-AF65-F5344CB8AC3E}">

</xml_diff>